<commit_message>
docs: add rtl smoke artifact coverage evidence
</commit_message>
<xml_diff>
--- a/reports/CacheSage-UC-defense-demo.pptx
+++ b/reports/CacheSage-UC-defense-demo.pptx
@@ -3628,7 +3628,7 @@
                 </a:solidFill>
                 <a:latin typeface="Microsoft YaHei"/>
               </a:rPr>
-              <a:t>1 passed</a:t>
+              <a:t>7</a:t>
             </a:r>
           </a:p>
         </p:txBody>
@@ -3663,7 +3663,7 @@
                 </a:solidFill>
                 <a:latin typeface="Microsoft YaHei"/>
               </a:rPr>
-              <a:t>上游 pytest smoke</a:t>
+              <a:t>RTL artifact manifest</a:t>
             </a:r>
           </a:p>
         </p:txBody>
@@ -3701,7 +3701,7 @@
         <p:spPr>
           <a:xfrm>
             <a:off x="658368" y="6080760"/>
-            <a:ext cx="6217920" cy="219456"/>
+            <a:ext cx="6675120" cy="219456"/>
           </a:xfrm>
           <a:prstGeom prst="rect">
             <a:avLst/>
@@ -3722,7 +3722,7 @@
                 </a:solidFill>
                 <a:latin typeface="Microsoft YaHei"/>
               </a:rPr>
-              <a:t>证据边界：smoke 已跑通；RTL measured coverage 尚未由上游 flow 导出。</a:t>
+              <a:t>证据边界：Python functional coverage 与 RTL smoke artifact/code coverage 分栏记录。</a:t>
             </a:r>
           </a:p>
         </p:txBody>
@@ -6227,7 +6227,7 @@
                 </a:solidFill>
                 <a:latin typeface="Microsoft YaHei"/>
               </a:rPr>
-              <a:t>make stdout/stderr 已保存到 JSON 摘要。</a:t>
+              <a:t>waveform / generated DUT / coverage candidate 已写入 manifest。</a:t>
             </a:r>
           </a:p>
         </p:txBody>
@@ -6297,7 +6297,7 @@
                 </a:solidFill>
                 <a:latin typeface="Microsoft YaHei"/>
               </a:rPr>
-              <a:t>RTL measured coverage 仍为空，等待 coverage flow 导出。</a:t>
+              <a:t>RTL code coverage 成功则写 LCOV 摘要，失败则写 not_exported 原因。</a:t>
             </a:r>
           </a:p>
         </p:txBody>
@@ -8879,7 +8879,7 @@
                 </a:solidFill>
                 <a:latin typeface="Microsoft YaHei"/>
               </a:rPr>
-              <a:t>报告拆成 planned coverage、Python harness measured coverage、RTL/Toffee measured coverage 三栏，真实 RTL 暂不夸大。</a:t>
+              <a:t>报告拆成 planned coverage、Python harness measured coverage、RTL smoke artifact、RTL code coverage 和后续 RTL functional coverage 几类证据，真实 RTL 暂不夸大。</a:t>
             </a:r>
           </a:p>
         </p:txBody>
@@ -9809,7 +9809,7 @@
                 </a:solidFill>
                 <a:latin typeface="Microsoft YaHei"/>
               </a:rPr>
-              <a:t>未声称：真实 RTL bug、RTL measured coverage。</a:t>
+              <a:t>未声称：真实 RTL bug、RTL functional coverage 已闭合。</a:t>
             </a:r>
           </a:p>
         </p:txBody>
@@ -9879,7 +9879,7 @@
                 </a:solidFill>
                 <a:latin typeface="Microsoft YaHei"/>
               </a:rPr>
-              <a:t>后续条件：waveform、coverage export、更长随机回归。</a:t>
+              <a:t>后续条件：更长随机回归、waveform 截图、真实 RTL functional coverage。</a:t>
             </a:r>
           </a:p>
         </p:txBody>

</xml_diff>